<commit_message>
Add team details, verify the CMS-0057-F claim, correct CoCo attribution
Deck slide 1 now carries the real team details.

Slide 2 previously asserted CMS-0057-F requirements from memory. Checked
against CMS's own fact sheet and replaced with the specifics: 72 hours
expedited, 7 calendar days standard, a specific reason required for every
denial, in force for impacted payers since 1 January 2026. A precise
citation is stronger than a vague one, and a wrong one on the Problem
Brief would undermine the rest of the slide.

Corrected the CoCo attribution in the README and on the architecture
slide. Both claimed CoCo "drove schema iteration and debugged the console
in-product". It did not. CoCo read the parsed policy and produced the
criteria tree, blind, and its reading was better than the hand-authored
key — that is the whole claim, and it is a better one for being true.

Renamed CLAUDE.md to ENGINEERING_NOTES.md and updated references.
</commit_message>
<xml_diff>
--- a/docs/verity-prototype.pptx
+++ b/docs/verity-prototype.pptx
@@ -3299,7 +3299,7 @@
                 </a:solidFill>
                 <a:latin typeface="Arial"/>
               </a:rPr>
-              <a:t>[TEAM NAME]</a:t>
+              <a:t>Coyot</a:t>
             </a:r>
           </a:p>
         </p:txBody>
@@ -3467,7 +3467,7 @@
                 </a:solidFill>
                 <a:latin typeface="Arial"/>
               </a:rPr>
-              <a:t>[TEAM LEADER NAME]</a:t>
+              <a:t>Priyanka Karmakar</a:t>
             </a:r>
           </a:p>
         </p:txBody>
@@ -3551,7 +3551,7 @@
                 </a:solidFill>
                 <a:latin typeface="Arial"/>
               </a:rPr>
-              <a:t>[TEAM SIZE]</a:t>
+              <a:t>2 — Priyanka Karmakar (lead), Mohammed Favas</a:t>
             </a:r>
           </a:p>
         </p:txBody>
@@ -4064,7 +4064,7 @@
                 </a:solidFill>
                 <a:latin typeface="Arial"/>
               </a:rPr>
-              <a:t>CMS-0057-F requires payers to return prior-authorization decisions within fixed windows and to state a specific reason for each. "The model decided" is not a reason. Every criterion must be individually defensible and traceable to a source.</a:t>
+              <a:t>Since January 2026, CMS-0057-F requires impacted payers to return prior-authorization decisions within 72 hours (expedited) or 7 calendar days (standard), and to give a specific reason for every denial. "The model decided" is not a reason. Each criterion must be individually defensible and traceable to a source.</a:t>
             </a:r>
           </a:p>
         </p:txBody>
@@ -6691,7 +6691,7 @@
                 </a:solidFill>
                 <a:latin typeface="Arial"/>
               </a:rPr>
-              <a:t> converts parsed policy prose into the criteria tree, and is scored blind against a held-out answer key. CoCo also drove schema iteration and debugged the console in-product.</a:t>
+              <a:t> converts parsed policy prose into the criteria tree, scored blind against a held-out answer key. It recovered every node independently and added two the hand-authored key was missing.</a:t>
             </a:r>
           </a:p>
         </p:txBody>

</xml_diff>

<commit_message>
Deck and demo script updated for on-demand member review
Deck: the demo slide no longer reads as "this works for three people".
Adds a callout that any of the 5,003 members is reviewable live, and the
Impact slide's scale claim now leads with that rather than with adding
policies. Slide 5's vertical rhythm tightened to keep the new callout
clear of the gradient footer.

Script: rewritten rather than patched, so the timings are coherent. The
live-search beat is marked optional with an explicit instruction to bank
the safe take first, and carries the one line that must be said out loud
- that a wall of NO EVIDENCE is the system refusing to guess about a
contraindication, not a broken screen. Adds a queue-reset snippet, since
a live search leaves a real request behind.
</commit_message>
<xml_diff>
--- a/docs/verity-prototype.pptx
+++ b/docs/verity-prototype.pptx
@@ -6873,7 +6873,7 @@
         <p:spPr>
           <a:xfrm>
             <a:off x="420624" y="1682495"/>
-            <a:ext cx="4050791" cy="1188720"/>
+            <a:ext cx="4050791" cy="1060704"/>
           </a:xfrm>
           <a:prstGeom prst="roundRect">
             <a:avLst>
@@ -6994,7 +6994,7 @@
         <p:spPr>
           <a:xfrm>
             <a:off x="4672583" y="1682495"/>
-            <a:ext cx="4050791" cy="1188720"/>
+            <a:ext cx="4050791" cy="1060704"/>
           </a:xfrm>
           <a:prstGeom prst="roundRect">
             <a:avLst>
@@ -7114,8 +7114,8 @@
         </p:nvSpPr>
         <p:spPr>
           <a:xfrm>
-            <a:off x="420624" y="2999232"/>
-            <a:ext cx="8302751" cy="512064"/>
+            <a:off x="420624" y="2852928"/>
+            <a:ext cx="8302751" cy="475488"/>
           </a:xfrm>
           <a:prstGeom prst="roundRect">
             <a:avLst>
@@ -7185,7 +7185,7 @@
         </p:nvSpPr>
         <p:spPr>
           <a:xfrm>
-            <a:off x="420624" y="3639311"/>
+            <a:off x="420624" y="3419856"/>
             <a:ext cx="8302751" cy="201168"/>
           </a:xfrm>
           <a:prstGeom prst="rect">
@@ -7214,7 +7214,7 @@
                 </a:solidFill>
                 <a:latin typeface="Arial"/>
               </a:rPr>
-              <a:t>THE SAME REVIEW, THREE MEMBERS</a:t>
+              <a:t>THREE CASES, THREE DIFFERENT PATHS</a:t>
             </a:r>
           </a:p>
         </p:txBody>
@@ -7227,7 +7227,7 @@
         </p:nvSpPr>
         <p:spPr>
           <a:xfrm>
-            <a:off x="420624" y="3895343"/>
+            <a:off x="420624" y="3648456"/>
             <a:ext cx="1170432" cy="182880"/>
           </a:xfrm>
           <a:prstGeom prst="rect">
@@ -7269,7 +7269,7 @@
         </p:nvSpPr>
         <p:spPr>
           <a:xfrm>
-            <a:off x="1627632" y="3877055"/>
+            <a:off x="1627632" y="3630168"/>
             <a:ext cx="676656" cy="173736"/>
           </a:xfrm>
           <a:prstGeom prst="roundRect">
@@ -7331,7 +7331,7 @@
         </p:nvSpPr>
         <p:spPr>
           <a:xfrm>
-            <a:off x="2395728" y="3886199"/>
+            <a:off x="2395728" y="3639312"/>
             <a:ext cx="6327647" cy="310896"/>
           </a:xfrm>
           <a:prstGeom prst="rect">
@@ -7373,7 +7373,7 @@
         </p:nvSpPr>
         <p:spPr>
           <a:xfrm>
-            <a:off x="420624" y="4279391"/>
+            <a:off x="420624" y="3968496"/>
             <a:ext cx="1170432" cy="182880"/>
           </a:xfrm>
           <a:prstGeom prst="rect">
@@ -7415,7 +7415,7 @@
         </p:nvSpPr>
         <p:spPr>
           <a:xfrm>
-            <a:off x="1627632" y="4261103"/>
+            <a:off x="1627632" y="3950208"/>
             <a:ext cx="676656" cy="173736"/>
           </a:xfrm>
           <a:prstGeom prst="roundRect">
@@ -7477,7 +7477,7 @@
         </p:nvSpPr>
         <p:spPr>
           <a:xfrm>
-            <a:off x="2395728" y="4270247"/>
+            <a:off x="2395728" y="3959352"/>
             <a:ext cx="6327647" cy="310896"/>
           </a:xfrm>
           <a:prstGeom prst="rect">
@@ -7519,7 +7519,7 @@
         </p:nvSpPr>
         <p:spPr>
           <a:xfrm>
-            <a:off x="420624" y="4663439"/>
+            <a:off x="420624" y="4288536"/>
             <a:ext cx="1170432" cy="182880"/>
           </a:xfrm>
           <a:prstGeom prst="rect">
@@ -7561,7 +7561,7 @@
         </p:nvSpPr>
         <p:spPr>
           <a:xfrm>
-            <a:off x="1627632" y="4645151"/>
+            <a:off x="1627632" y="4270248"/>
             <a:ext cx="676656" cy="173736"/>
           </a:xfrm>
           <a:prstGeom prst="roundRect">
@@ -7623,7 +7623,7 @@
         </p:nvSpPr>
         <p:spPr>
           <a:xfrm>
-            <a:off x="2395728" y="4654295"/>
+            <a:off x="2395728" y="4279392"/>
             <a:ext cx="6327647" cy="310896"/>
           </a:xfrm>
           <a:prstGeom prst="rect">
@@ -7653,6 +7653,79 @@
                 <a:latin typeface="Arial"/>
               </a:rPr>
               <a:t>Every criterion passes, but a family history of medullary thyroid carcinoma is buried in a consult note. §5.1 fires.</a:t>
+            </a:r>
+          </a:p>
+        </p:txBody>
+      </p:sp>
+      <p:sp>
+        <p:nvSpPr>
+          <p:cNvPr id="19" name="Rounded Rectangle 18"/>
+          <p:cNvSpPr/>
+          <p:nvPr/>
+        </p:nvSpPr>
+        <p:spPr>
+          <a:xfrm>
+            <a:off x="420624" y="4626864"/>
+            <a:ext cx="8302751" cy="274320"/>
+          </a:xfrm>
+          <a:prstGeom prst="roundRect">
+            <a:avLst>
+              <a:gd name="adj" fmla="val 10000"/>
+            </a:avLst>
+          </a:prstGeom>
+          <a:solidFill>
+            <a:srgbClr val="FFFFFF"/>
+          </a:solidFill>
+          <a:ln w="9525">
+            <a:solidFill>
+              <a:srgbClr val="1BA0F2"/>
+            </a:solidFill>
+          </a:ln>
+          <a:effectLst/>
+        </p:spPr>
+        <p:style>
+          <a:lnRef idx="1">
+            <a:schemeClr val="accent1"/>
+          </a:lnRef>
+          <a:fillRef idx="3">
+            <a:schemeClr val="accent1"/>
+          </a:fillRef>
+          <a:effectRef idx="2">
+            <a:schemeClr val="accent1"/>
+          </a:effectRef>
+          <a:fontRef idx="minor">
+            <a:schemeClr val="lt1"/>
+          </a:fontRef>
+        </p:style>
+        <p:txBody>
+          <a:bodyPr rtlCol="0" anchor="ctr" wrap="square" lIns="73152" rIns="73152"/>
+          <a:lstStyle/>
+          <a:p>
+            <a:pPr algn="l">
+              <a:spcBef>
+                <a:spcPts val="0"/>
+              </a:spcBef>
+              <a:spcAft>
+                <a:spcPts val="0"/>
+              </a:spcAft>
+            </a:pPr>
+            <a:r>
+              <a:rPr sz="850" b="1" i="0">
+                <a:solidFill>
+                  <a:srgbClr val="1BA0F2"/>
+                </a:solidFill>
+                <a:latin typeface="Arial"/>
+              </a:rPr>
+              <a:t>Not just these three.  </a:t>
+            </a:r>
+            <a:r>
+              <a:rPr sz="850" b="0" i="0">
+                <a:solidFill>
+                  <a:srgbClr val="334045"/>
+                </a:solidFill>
+                <a:latin typeface="Arial"/>
+              </a:rPr>
+              <a:t>Any of the 5,003 members can be reviewed on demand — the same 21 criteria, adjudicated live in about 40 seconds.</a:t>
             </a:r>
           </a:p>
         </p:txBody>
@@ -9806,7 +9879,7 @@
                 </a:solidFill>
                 <a:latin typeface="Arial"/>
               </a:rPr>
-              <a:t>Scales by policy</a:t>
+              <a:t>Already population-scale</a:t>
             </a:r>
           </a:p>
           <a:p>
@@ -9825,7 +9898,7 @@
                 </a:solidFill>
                 <a:latin typeface="Arial"/>
               </a:rPr>
-              <a:t>Adding a policy is adding a PDF. Parsing, extraction and scoring already run unattended.</a:t>
+              <a:t>Any of the 5,003 members is reviewable on demand today. Adding a policy is adding a PDF — parsing, extraction and scoring already run unattended.</a:t>
             </a:r>
           </a:p>
         </p:txBody>

</xml_diff>